<commit_message>
AutomaTivio: book Deb sai como Debêntures na alocação real dos ALT
Co-Authored-By: Claude Opus 5.5 <noreply@anthropic.com>
</commit_message>
<xml_diff>
--- a/AutomaTivio/saida/2026-08/pptx/Tivio ALT Light - Relatório de Gestão - Agosto 2026.pptx
+++ b/AutomaTivio/saida/2026-08/pptx/Tivio ALT Light - Relatório de Gestão - Agosto 2026.pptx
@@ -4694,16 +4694,16 @@
         </p:nvSpPr>
         <p:spPr>
           <a:xfrm>
-            <a:off x="3258832" y="6089934"/>
-            <a:ext cx="1553107" cy="292477"/>
-          </a:xfrm>
-          <a:prstGeom prst="rect">
-            <a:avLst/>
-          </a:prstGeom>
-          <a:noFill/>
-        </p:spPr>
-        <p:txBody>
-          <a:bodyPr wrap="square" lIns="0" rIns="0" tIns="0" bIns="0" anchor="t"/>
+            <a:off x="3258832" y="6231211"/>
+            <a:ext cx="1615231" cy="151200"/>
+          </a:xfrm>
+          <a:prstGeom prst="rect">
+            <a:avLst/>
+          </a:prstGeom>
+          <a:noFill/>
+        </p:spPr>
+        <p:txBody>
+          <a:bodyPr wrap="none" lIns="0" rIns="0" tIns="0" bIns="0" anchor="t"/>
           <a:lstStyle/>
           <a:p>
             <a:pPr algn="l">
@@ -4718,23 +4718,7 @@
                 </a:solidFill>
                 <a:latin typeface="Versos"/>
               </a:rPr>
-              <a:t>Crédito</a:t>
-            </a:r>
-          </a:p>
-          <a:p>
-            <a:pPr algn="l">
-              <a:lnSpc>
-                <a:spcPts val="1113"/>
-              </a:lnSpc>
-            </a:pPr>
-            <a:r>
-              <a:rPr sz="1012" b="1" i="0">
-                <a:solidFill>
-                  <a:srgbClr val="FFFFFF"/>
-                </a:solidFill>
-                <a:latin typeface="Versos"/>
-              </a:rPr>
-              <a:t>Privado</a:t>
+              <a:t>Debêntures</a:t>
             </a:r>
           </a:p>
         </p:txBody>
@@ -5032,7 +5016,7 @@
         <p:spPr>
           <a:xfrm>
             <a:off x="1538578" y="6743638"/>
-            <a:ext cx="1083659" cy="113400"/>
+            <a:ext cx="904790" cy="113400"/>
           </a:xfrm>
           <a:prstGeom prst="rect">
             <a:avLst/>
@@ -5055,7 +5039,7 @@
                 </a:solidFill>
                 <a:latin typeface="Versos"/>
               </a:rPr>
-              <a:t>Crédito Privado </a:t>
+              <a:t>Debêntures </a:t>
             </a:r>
             <a:r>
               <a:rPr sz="744" b="1" i="0">
@@ -5077,7 +5061,7 @@
         </p:nvSpPr>
         <p:spPr>
           <a:xfrm>
-            <a:off x="2845158" y="6743638"/>
+            <a:off x="2673168" y="6743638"/>
             <a:ext cx="1226780" cy="113400"/>
           </a:xfrm>
           <a:prstGeom prst="rect">
@@ -5123,7 +5107,7 @@
         </p:nvSpPr>
         <p:spPr>
           <a:xfrm>
-            <a:off x="4289355" y="6743638"/>
+            <a:off x="4117365" y="6743638"/>
             <a:ext cx="676657" cy="113400"/>
           </a:xfrm>
           <a:prstGeom prst="rect">
@@ -5169,7 +5153,7 @@
         </p:nvSpPr>
         <p:spPr>
           <a:xfrm>
-            <a:off x="5204587" y="6743638"/>
+            <a:off x="5032597" y="6743638"/>
             <a:ext cx="441768" cy="113400"/>
           </a:xfrm>
           <a:prstGeom prst="rect">

</xml_diff>